<commit_message>
Add auto layouts, icon library, charts and copy check to deck builder
- Planner picks layouts from point count and kind, splits overflow into
  balanced continuation slides, and flags over-long copy (--plan)
- 106 brand-coloured Lucide line icons with keyword auto-matching,
  shared by slides (PNG) and graphics (inline SVG)
- New icon_grid and native chart layouts; dated timelines; stat icons
- Image slides can embed a rendered graphics-skill template

Co-Authored-By: Claude Opus 5.5 (1M context) <noreply@anthropic.com>
</commit_message>
<xml_diff>
--- a/.claude/skills/frontier-commons-slides/examples/sample-deck.pptx
+++ b/.claude/skills/frontier-commons-slides/examples/sample-deck.pptx
@@ -6141,8 +6141,8 @@
         </p:nvSpPr>
         <p:spPr>
           <a:xfrm>
-            <a:off x="731520" y="1905000"/>
-            <a:ext cx="2442133" cy="3710940"/>
+            <a:off x="731520" y="1577340"/>
+            <a:ext cx="2442133" cy="4366260"/>
           </a:xfrm>
           <a:prstGeom prst="roundRect">
             <a:avLst>
@@ -6187,7 +6187,7 @@
         </p:nvSpPr>
         <p:spPr>
           <a:xfrm>
-            <a:off x="1005840" y="2316480"/>
+            <a:off x="1005840" y="1988820"/>
             <a:ext cx="1893493" cy="457200"/>
           </a:xfrm>
           <a:prstGeom prst="rect">
@@ -6226,7 +6226,7 @@
         </p:nvSpPr>
         <p:spPr>
           <a:xfrm>
-            <a:off x="1083906" y="2819400"/>
+            <a:off x="1083906" y="2491740"/>
             <a:ext cx="1737360" cy="31750"/>
           </a:xfrm>
           <a:prstGeom prst="rect">
@@ -6270,7 +6270,7 @@
         </p:nvSpPr>
         <p:spPr>
           <a:xfrm>
-            <a:off x="1005840" y="3002280"/>
+            <a:off x="1005840" y="2674620"/>
             <a:ext cx="1893493" cy="731520"/>
           </a:xfrm>
           <a:prstGeom prst="rect">
@@ -6301,16 +6301,40 @@
           </a:p>
         </p:txBody>
       </p:sp>
-      <p:sp>
-        <p:nvSpPr>
-          <p:cNvPr id="7" name="TextBox 6"/>
+      <p:pic>
+        <p:nvPicPr>
+          <p:cNvPr id="7" name="Picture 6" descr="door-open.png"/>
+          <p:cNvPicPr>
+            <a:picLocks noChangeAspect="1"/>
+          </p:cNvPicPr>
+          <p:nvPr/>
+        </p:nvPicPr>
+        <p:blipFill>
+          <a:blip r:embed="rId2"/>
+          <a:stretch>
+            <a:fillRect/>
+          </a:stretch>
+        </p:blipFill>
+        <p:spPr>
+          <a:xfrm>
+            <a:off x="1609686" y="3497580"/>
+            <a:ext cx="685800" cy="685800"/>
+          </a:xfrm>
+          <a:prstGeom prst="rect">
+            <a:avLst/>
+          </a:prstGeom>
+        </p:spPr>
+      </p:pic>
+      <p:sp>
+        <p:nvSpPr>
+          <p:cNvPr id="8" name="TextBox 7"/>
           <p:cNvSpPr txBox="1"/>
           <p:nvPr/>
         </p:nvSpPr>
         <p:spPr>
           <a:xfrm>
-            <a:off x="1005840" y="3916680"/>
-            <a:ext cx="1893493" cy="1470660"/>
+            <a:off x="1005840" y="4457700"/>
+            <a:ext cx="1893493" cy="1257300"/>
           </a:xfrm>
           <a:prstGeom prst="rect">
             <a:avLst/>
@@ -6342,14 +6366,14 @@
       </p:sp>
       <p:sp>
         <p:nvSpPr>
-          <p:cNvPr id="8" name="Rounded Rectangle 7"/>
+          <p:cNvPr id="9" name="Rounded Rectangle 8"/>
           <p:cNvSpPr/>
           <p:nvPr/>
         </p:nvSpPr>
         <p:spPr>
           <a:xfrm>
-            <a:off x="3493693" y="1905000"/>
-            <a:ext cx="2442133" cy="3710940"/>
+            <a:off x="3493693" y="1577340"/>
+            <a:ext cx="2442133" cy="4366260"/>
           </a:xfrm>
           <a:prstGeom prst="roundRect">
             <a:avLst>
@@ -6388,13 +6412,13 @@
       </p:sp>
       <p:sp>
         <p:nvSpPr>
-          <p:cNvPr id="9" name="TextBox 8"/>
+          <p:cNvPr id="10" name="TextBox 9"/>
           <p:cNvSpPr txBox="1"/>
           <p:nvPr/>
         </p:nvSpPr>
         <p:spPr>
           <a:xfrm>
-            <a:off x="3768013" y="2316480"/>
+            <a:off x="3768013" y="1988820"/>
             <a:ext cx="1893493" cy="457200"/>
           </a:xfrm>
           <a:prstGeom prst="rect">
@@ -6427,13 +6451,13 @@
       </p:sp>
       <p:sp>
         <p:nvSpPr>
-          <p:cNvPr id="10" name="Rectangle 9"/>
+          <p:cNvPr id="11" name="Rectangle 10"/>
           <p:cNvSpPr/>
           <p:nvPr/>
         </p:nvSpPr>
         <p:spPr>
           <a:xfrm>
-            <a:off x="3846079" y="2819400"/>
+            <a:off x="3846079" y="2491740"/>
             <a:ext cx="1737360" cy="31750"/>
           </a:xfrm>
           <a:prstGeom prst="rect">
@@ -6471,13 +6495,13 @@
       </p:sp>
       <p:sp>
         <p:nvSpPr>
-          <p:cNvPr id="11" name="TextBox 10"/>
+          <p:cNvPr id="12" name="TextBox 11"/>
           <p:cNvSpPr txBox="1"/>
           <p:nvPr/>
         </p:nvSpPr>
         <p:spPr>
           <a:xfrm>
-            <a:off x="3768013" y="3002280"/>
+            <a:off x="3768013" y="2674620"/>
             <a:ext cx="1893493" cy="731520"/>
           </a:xfrm>
           <a:prstGeom prst="rect">
@@ -6508,16 +6532,40 @@
           </a:p>
         </p:txBody>
       </p:sp>
-      <p:sp>
-        <p:nvSpPr>
-          <p:cNvPr id="12" name="TextBox 11"/>
+      <p:pic>
+        <p:nvPicPr>
+          <p:cNvPr id="13" name="Picture 12" descr="handshake.png"/>
+          <p:cNvPicPr>
+            <a:picLocks noChangeAspect="1"/>
+          </p:cNvPicPr>
+          <p:nvPr/>
+        </p:nvPicPr>
+        <p:blipFill>
+          <a:blip r:embed="rId3"/>
+          <a:stretch>
+            <a:fillRect/>
+          </a:stretch>
+        </p:blipFill>
+        <p:spPr>
+          <a:xfrm>
+            <a:off x="4371859" y="3497580"/>
+            <a:ext cx="685800" cy="685800"/>
+          </a:xfrm>
+          <a:prstGeom prst="rect">
+            <a:avLst/>
+          </a:prstGeom>
+        </p:spPr>
+      </p:pic>
+      <p:sp>
+        <p:nvSpPr>
+          <p:cNvPr id="14" name="TextBox 13"/>
           <p:cNvSpPr txBox="1"/>
           <p:nvPr/>
         </p:nvSpPr>
         <p:spPr>
           <a:xfrm>
-            <a:off x="3768013" y="3916680"/>
-            <a:ext cx="1893493" cy="1470660"/>
+            <a:off x="3768013" y="4457700"/>
+            <a:ext cx="1893493" cy="1257300"/>
           </a:xfrm>
           <a:prstGeom prst="rect">
             <a:avLst/>
@@ -6549,14 +6597,14 @@
       </p:sp>
       <p:sp>
         <p:nvSpPr>
-          <p:cNvPr id="13" name="Rounded Rectangle 12"/>
+          <p:cNvPr id="15" name="Rounded Rectangle 14"/>
           <p:cNvSpPr/>
           <p:nvPr/>
         </p:nvSpPr>
         <p:spPr>
           <a:xfrm>
-            <a:off x="6255867" y="1905000"/>
-            <a:ext cx="2442133" cy="3710940"/>
+            <a:off x="6255867" y="1577340"/>
+            <a:ext cx="2442133" cy="4366260"/>
           </a:xfrm>
           <a:prstGeom prst="roundRect">
             <a:avLst>
@@ -6595,13 +6643,13 @@
       </p:sp>
       <p:sp>
         <p:nvSpPr>
-          <p:cNvPr id="14" name="TextBox 13"/>
+          <p:cNvPr id="16" name="TextBox 15"/>
           <p:cNvSpPr txBox="1"/>
           <p:nvPr/>
         </p:nvSpPr>
         <p:spPr>
           <a:xfrm>
-            <a:off x="6530187" y="2316480"/>
+            <a:off x="6530187" y="1988820"/>
             <a:ext cx="1893493" cy="457200"/>
           </a:xfrm>
           <a:prstGeom prst="rect">
@@ -6634,13 +6682,13 @@
       </p:sp>
       <p:sp>
         <p:nvSpPr>
-          <p:cNvPr id="15" name="Rectangle 14"/>
+          <p:cNvPr id="17" name="Rectangle 16"/>
           <p:cNvSpPr/>
           <p:nvPr/>
         </p:nvSpPr>
         <p:spPr>
           <a:xfrm>
-            <a:off x="6608253" y="2819400"/>
+            <a:off x="6608253" y="2491740"/>
             <a:ext cx="1737360" cy="31750"/>
           </a:xfrm>
           <a:prstGeom prst="rect">
@@ -6678,13 +6726,13 @@
       </p:sp>
       <p:sp>
         <p:nvSpPr>
-          <p:cNvPr id="16" name="TextBox 15"/>
+          <p:cNvPr id="18" name="TextBox 17"/>
           <p:cNvSpPr txBox="1"/>
           <p:nvPr/>
         </p:nvSpPr>
         <p:spPr>
           <a:xfrm>
-            <a:off x="6530187" y="3002280"/>
+            <a:off x="6530187" y="2674620"/>
             <a:ext cx="1893493" cy="731520"/>
           </a:xfrm>
           <a:prstGeom prst="rect">
@@ -6715,16 +6763,40 @@
           </a:p>
         </p:txBody>
       </p:sp>
-      <p:sp>
-        <p:nvSpPr>
-          <p:cNvPr id="17" name="TextBox 16"/>
+      <p:pic>
+        <p:nvPicPr>
+          <p:cNvPr id="19" name="Picture 18" descr="lightbulb.png"/>
+          <p:cNvPicPr>
+            <a:picLocks noChangeAspect="1"/>
+          </p:cNvPicPr>
+          <p:nvPr/>
+        </p:nvPicPr>
+        <p:blipFill>
+          <a:blip r:embed="rId4"/>
+          <a:stretch>
+            <a:fillRect/>
+          </a:stretch>
+        </p:blipFill>
+        <p:spPr>
+          <a:xfrm>
+            <a:off x="7134033" y="3497580"/>
+            <a:ext cx="685800" cy="685800"/>
+          </a:xfrm>
+          <a:prstGeom prst="rect">
+            <a:avLst/>
+          </a:prstGeom>
+        </p:spPr>
+      </p:pic>
+      <p:sp>
+        <p:nvSpPr>
+          <p:cNvPr id="20" name="TextBox 19"/>
           <p:cNvSpPr txBox="1"/>
           <p:nvPr/>
         </p:nvSpPr>
         <p:spPr>
           <a:xfrm>
-            <a:off x="6530187" y="3916680"/>
-            <a:ext cx="1893493" cy="1470660"/>
+            <a:off x="6530187" y="4457700"/>
+            <a:ext cx="1893493" cy="1257300"/>
           </a:xfrm>
           <a:prstGeom prst="rect">
             <a:avLst/>
@@ -6756,14 +6828,14 @@
       </p:sp>
       <p:sp>
         <p:nvSpPr>
-          <p:cNvPr id="18" name="Rounded Rectangle 17"/>
+          <p:cNvPr id="21" name="Rounded Rectangle 20"/>
           <p:cNvSpPr/>
           <p:nvPr/>
         </p:nvSpPr>
         <p:spPr>
           <a:xfrm>
-            <a:off x="9018041" y="1905000"/>
-            <a:ext cx="2442133" cy="3710940"/>
+            <a:off x="9018041" y="1577340"/>
+            <a:ext cx="2442133" cy="4366260"/>
           </a:xfrm>
           <a:prstGeom prst="roundRect">
             <a:avLst>
@@ -6802,13 +6874,13 @@
       </p:sp>
       <p:sp>
         <p:nvSpPr>
-          <p:cNvPr id="19" name="TextBox 18"/>
+          <p:cNvPr id="22" name="TextBox 21"/>
           <p:cNvSpPr txBox="1"/>
           <p:nvPr/>
         </p:nvSpPr>
         <p:spPr>
           <a:xfrm>
-            <a:off x="9292361" y="2316480"/>
+            <a:off x="9292361" y="1988820"/>
             <a:ext cx="1893493" cy="457200"/>
           </a:xfrm>
           <a:prstGeom prst="rect">
@@ -6841,13 +6913,13 @@
       </p:sp>
       <p:sp>
         <p:nvSpPr>
-          <p:cNvPr id="20" name="Rectangle 19"/>
+          <p:cNvPr id="23" name="Rectangle 22"/>
           <p:cNvSpPr/>
           <p:nvPr/>
         </p:nvSpPr>
         <p:spPr>
           <a:xfrm>
-            <a:off x="9370427" y="2819400"/>
+            <a:off x="9370427" y="2491740"/>
             <a:ext cx="1737360" cy="31750"/>
           </a:xfrm>
           <a:prstGeom prst="rect">
@@ -6885,13 +6957,13 @@
       </p:sp>
       <p:sp>
         <p:nvSpPr>
-          <p:cNvPr id="21" name="TextBox 20"/>
+          <p:cNvPr id="24" name="TextBox 23"/>
           <p:cNvSpPr txBox="1"/>
           <p:nvPr/>
         </p:nvSpPr>
         <p:spPr>
           <a:xfrm>
-            <a:off x="9292361" y="3002280"/>
+            <a:off x="9292361" y="2674620"/>
             <a:ext cx="1893493" cy="731520"/>
           </a:xfrm>
           <a:prstGeom prst="rect">
@@ -6922,16 +6994,40 @@
           </a:p>
         </p:txBody>
       </p:sp>
-      <p:sp>
-        <p:nvSpPr>
-          <p:cNvPr id="22" name="TextBox 21"/>
+      <p:pic>
+        <p:nvPicPr>
+          <p:cNvPr id="25" name="Picture 24" descr="globe.png"/>
+          <p:cNvPicPr>
+            <a:picLocks noChangeAspect="1"/>
+          </p:cNvPicPr>
+          <p:nvPr/>
+        </p:nvPicPr>
+        <p:blipFill>
+          <a:blip r:embed="rId5"/>
+          <a:stretch>
+            <a:fillRect/>
+          </a:stretch>
+        </p:blipFill>
+        <p:spPr>
+          <a:xfrm>
+            <a:off x="9896207" y="3497580"/>
+            <a:ext cx="685800" cy="685800"/>
+          </a:xfrm>
+          <a:prstGeom prst="rect">
+            <a:avLst/>
+          </a:prstGeom>
+        </p:spPr>
+      </p:pic>
+      <p:sp>
+        <p:nvSpPr>
+          <p:cNvPr id="26" name="TextBox 25"/>
           <p:cNvSpPr txBox="1"/>
           <p:nvPr/>
         </p:nvSpPr>
         <p:spPr>
           <a:xfrm>
-            <a:off x="9292361" y="3916680"/>
-            <a:ext cx="1893493" cy="1470660"/>
+            <a:off x="9292361" y="4457700"/>
+            <a:ext cx="1893493" cy="1257300"/>
           </a:xfrm>
           <a:prstGeom prst="rect">
             <a:avLst/>
@@ -6963,14 +7059,14 @@
       </p:sp>
       <p:pic>
         <p:nvPicPr>
-          <p:cNvPr id="23" name="Picture 22" descr="logo-icon-deep-blue.png"/>
+          <p:cNvPr id="27" name="Picture 26" descr="logo-icon-deep-blue.png"/>
           <p:cNvPicPr>
             <a:picLocks noChangeAspect="1"/>
           </p:cNvPicPr>
           <p:nvPr/>
         </p:nvPicPr>
         <p:blipFill>
-          <a:blip r:embed="rId2"/>
+          <a:blip r:embed="rId6"/>
           <a:stretch>
             <a:fillRect/>
           </a:stretch>
@@ -6987,7 +7083,7 @@
       </p:pic>
       <p:sp>
         <p:nvSpPr>
-          <p:cNvPr id="24" name="TextBox 23"/>
+          <p:cNvPr id="28" name="TextBox 27"/>
           <p:cNvSpPr txBox="1"/>
           <p:nvPr/>
         </p:nvSpPr>
@@ -7097,7 +7193,7 @@
         </p:nvSpPr>
         <p:spPr>
           <a:xfrm>
-            <a:off x="1804385" y="2655570"/>
+            <a:off x="1804385" y="2609850"/>
             <a:ext cx="8582924" cy="38100"/>
           </a:xfrm>
           <a:prstGeom prst="rect">
@@ -7141,8 +7237,8 @@
         </p:nvSpPr>
         <p:spPr>
           <a:xfrm>
-            <a:off x="1438625" y="2308860"/>
-            <a:ext cx="731520" cy="731520"/>
+            <a:off x="1392905" y="2217420"/>
+            <a:ext cx="822960" cy="822960"/>
           </a:xfrm>
           <a:prstGeom prst="ellipse">
             <a:avLst/>
@@ -7170,25 +7266,40 @@
           </a:fontRef>
         </p:style>
         <p:txBody>
-          <a:bodyPr rtlCol="0" anchor="ctr" lIns="0" rIns="0" tIns="0" bIns="0"/>
+          <a:bodyPr rtlCol="0" anchor="ctr"/>
           <a:lstStyle/>
           <a:p>
             <a:pPr algn="ctr"/>
-            <a:r>
-              <a:rPr sz="2200" b="1" i="0">
-                <a:solidFill>
-                  <a:srgbClr val="131416"/>
-                </a:solidFill>
-                <a:latin typeface="Inter"/>
-              </a:rPr>
-              <a:t>1</a:t>
-            </a:r>
-          </a:p>
-        </p:txBody>
-      </p:sp>
-      <p:sp>
-        <p:nvSpPr>
-          <p:cNvPr id="5" name="TextBox 4"/>
+          </a:p>
+        </p:txBody>
+      </p:sp>
+      <p:pic>
+        <p:nvPicPr>
+          <p:cNvPr id="5" name="Picture 4" descr="luggage.png"/>
+          <p:cNvPicPr>
+            <a:picLocks noChangeAspect="1"/>
+          </p:cNvPicPr>
+          <p:nvPr/>
+        </p:nvPicPr>
+        <p:blipFill>
+          <a:blip r:embed="rId2"/>
+          <a:stretch>
+            <a:fillRect/>
+          </a:stretch>
+        </p:blipFill>
+        <p:spPr>
+          <a:xfrm>
+            <a:off x="1590415" y="2414930"/>
+            <a:ext cx="427940" cy="427940"/>
+          </a:xfrm>
+          <a:prstGeom prst="rect">
+            <a:avLst/>
+          </a:prstGeom>
+        </p:spPr>
+      </p:pic>
+      <p:sp>
+        <p:nvSpPr>
+          <p:cNvPr id="6" name="TextBox 5"/>
           <p:cNvSpPr txBox="1"/>
           <p:nvPr/>
         </p:nvSpPr>
@@ -7220,14 +7331,14 @@
                 </a:solidFill>
                 <a:latin typeface="DM Sans"/>
               </a:rPr>
-              <a:t>Pre-Arrival</a:t>
-            </a:r>
-          </a:p>
-        </p:txBody>
-      </p:sp>
-      <p:sp>
-        <p:nvSpPr>
-          <p:cNvPr id="6" name="TextBox 5"/>
+              <a:t>1. Pre-Arrival</a:t>
+            </a:r>
+          </a:p>
+        </p:txBody>
+      </p:sp>
+      <p:sp>
+        <p:nvSpPr>
+          <p:cNvPr id="7" name="TextBox 6"/>
           <p:cNvSpPr txBox="1"/>
           <p:nvPr/>
         </p:nvSpPr>
@@ -7266,14 +7377,14 @@
       </p:sp>
       <p:sp>
         <p:nvSpPr>
-          <p:cNvPr id="7" name="Oval 6"/>
+          <p:cNvPr id="8" name="Oval 7"/>
           <p:cNvSpPr/>
           <p:nvPr/>
         </p:nvSpPr>
         <p:spPr>
           <a:xfrm>
-            <a:off x="3584356" y="2308860"/>
-            <a:ext cx="731520" cy="731520"/>
+            <a:off x="3538636" y="2217420"/>
+            <a:ext cx="822960" cy="822960"/>
           </a:xfrm>
           <a:prstGeom prst="ellipse">
             <a:avLst/>
@@ -7301,25 +7412,40 @@
           </a:fontRef>
         </p:style>
         <p:txBody>
-          <a:bodyPr rtlCol="0" anchor="ctr" lIns="0" rIns="0" tIns="0" bIns="0"/>
+          <a:bodyPr rtlCol="0" anchor="ctr"/>
           <a:lstStyle/>
           <a:p>
             <a:pPr algn="ctr"/>
-            <a:r>
-              <a:rPr sz="2200" b="1" i="0">
-                <a:solidFill>
-                  <a:srgbClr val="131416"/>
-                </a:solidFill>
-                <a:latin typeface="Inter"/>
-              </a:rPr>
-              <a:t>2</a:t>
-            </a:r>
-          </a:p>
-        </p:txBody>
-      </p:sp>
-      <p:sp>
-        <p:nvSpPr>
-          <p:cNvPr id="8" name="TextBox 7"/>
+          </a:p>
+        </p:txBody>
+      </p:sp>
+      <p:pic>
+        <p:nvPicPr>
+          <p:cNvPr id="9" name="Picture 8" descr="plane-landing.png"/>
+          <p:cNvPicPr>
+            <a:picLocks noChangeAspect="1"/>
+          </p:cNvPicPr>
+          <p:nvPr/>
+        </p:nvPicPr>
+        <p:blipFill>
+          <a:blip r:embed="rId3"/>
+          <a:stretch>
+            <a:fillRect/>
+          </a:stretch>
+        </p:blipFill>
+        <p:spPr>
+          <a:xfrm>
+            <a:off x="3736146" y="2414930"/>
+            <a:ext cx="427940" cy="427940"/>
+          </a:xfrm>
+          <a:prstGeom prst="rect">
+            <a:avLst/>
+          </a:prstGeom>
+        </p:spPr>
+      </p:pic>
+      <p:sp>
+        <p:nvSpPr>
+          <p:cNvPr id="10" name="TextBox 9"/>
           <p:cNvSpPr txBox="1"/>
           <p:nvPr/>
         </p:nvSpPr>
@@ -7351,14 +7477,14 @@
                 </a:solidFill>
                 <a:latin typeface="DM Sans"/>
               </a:rPr>
-              <a:t>Arrival &amp; Orientation</a:t>
-            </a:r>
-          </a:p>
-        </p:txBody>
-      </p:sp>
-      <p:sp>
-        <p:nvSpPr>
-          <p:cNvPr id="9" name="TextBox 8"/>
+              <a:t>2. Arrival &amp; Orientation</a:t>
+            </a:r>
+          </a:p>
+        </p:txBody>
+      </p:sp>
+      <p:sp>
+        <p:nvSpPr>
+          <p:cNvPr id="11" name="TextBox 10"/>
           <p:cNvSpPr txBox="1"/>
           <p:nvPr/>
         </p:nvSpPr>
@@ -7397,14 +7523,14 @@
       </p:sp>
       <p:sp>
         <p:nvSpPr>
-          <p:cNvPr id="10" name="Oval 9"/>
+          <p:cNvPr id="12" name="Oval 11"/>
           <p:cNvSpPr/>
           <p:nvPr/>
         </p:nvSpPr>
         <p:spPr>
           <a:xfrm>
-            <a:off x="5730087" y="2308860"/>
-            <a:ext cx="731520" cy="731520"/>
+            <a:off x="5684367" y="2217420"/>
+            <a:ext cx="822960" cy="822960"/>
           </a:xfrm>
           <a:prstGeom prst="ellipse">
             <a:avLst/>
@@ -7432,25 +7558,40 @@
           </a:fontRef>
         </p:style>
         <p:txBody>
-          <a:bodyPr rtlCol="0" anchor="ctr" lIns="0" rIns="0" tIns="0" bIns="0"/>
+          <a:bodyPr rtlCol="0" anchor="ctr"/>
           <a:lstStyle/>
           <a:p>
             <a:pPr algn="ctr"/>
-            <a:r>
-              <a:rPr sz="2200" b="1" i="0">
-                <a:solidFill>
-                  <a:srgbClr val="131416"/>
-                </a:solidFill>
-                <a:latin typeface="Inter"/>
-              </a:rPr>
-              <a:t>3</a:t>
-            </a:r>
-          </a:p>
-        </p:txBody>
-      </p:sp>
-      <p:sp>
-        <p:nvSpPr>
-          <p:cNvPr id="11" name="TextBox 10"/>
+          </a:p>
+        </p:txBody>
+      </p:sp>
+      <p:pic>
+        <p:nvPicPr>
+          <p:cNvPr id="13" name="Picture 12" descr="puzzle.png"/>
+          <p:cNvPicPr>
+            <a:picLocks noChangeAspect="1"/>
+          </p:cNvPicPr>
+          <p:nvPr/>
+        </p:nvPicPr>
+        <p:blipFill>
+          <a:blip r:embed="rId4"/>
+          <a:stretch>
+            <a:fillRect/>
+          </a:stretch>
+        </p:blipFill>
+        <p:spPr>
+          <a:xfrm>
+            <a:off x="5881877" y="2414930"/>
+            <a:ext cx="427940" cy="427940"/>
+          </a:xfrm>
+          <a:prstGeom prst="rect">
+            <a:avLst/>
+          </a:prstGeom>
+        </p:spPr>
+      </p:pic>
+      <p:sp>
+        <p:nvSpPr>
+          <p:cNvPr id="14" name="TextBox 13"/>
           <p:cNvSpPr txBox="1"/>
           <p:nvPr/>
         </p:nvSpPr>
@@ -7482,14 +7623,14 @@
                 </a:solidFill>
                 <a:latin typeface="DM Sans"/>
               </a:rPr>
-              <a:t>Integration</a:t>
-            </a:r>
-          </a:p>
-        </p:txBody>
-      </p:sp>
-      <p:sp>
-        <p:nvSpPr>
-          <p:cNvPr id="12" name="TextBox 11"/>
+              <a:t>3. Integration</a:t>
+            </a:r>
+          </a:p>
+        </p:txBody>
+      </p:sp>
+      <p:sp>
+        <p:nvSpPr>
+          <p:cNvPr id="15" name="TextBox 14"/>
           <p:cNvSpPr txBox="1"/>
           <p:nvPr/>
         </p:nvSpPr>
@@ -7528,14 +7669,14 @@
       </p:sp>
       <p:sp>
         <p:nvSpPr>
-          <p:cNvPr id="13" name="Oval 12"/>
+          <p:cNvPr id="16" name="Oval 15"/>
           <p:cNvSpPr/>
           <p:nvPr/>
         </p:nvSpPr>
         <p:spPr>
           <a:xfrm>
-            <a:off x="7875818" y="2308860"/>
-            <a:ext cx="731520" cy="731520"/>
+            <a:off x="7830098" y="2217420"/>
+            <a:ext cx="822960" cy="822960"/>
           </a:xfrm>
           <a:prstGeom prst="ellipse">
             <a:avLst/>
@@ -7563,25 +7704,40 @@
           </a:fontRef>
         </p:style>
         <p:txBody>
-          <a:bodyPr rtlCol="0" anchor="ctr" lIns="0" rIns="0" tIns="0" bIns="0"/>
+          <a:bodyPr rtlCol="0" anchor="ctr"/>
           <a:lstStyle/>
           <a:p>
             <a:pPr algn="ctr"/>
-            <a:r>
-              <a:rPr sz="2200" b="1" i="0">
-                <a:solidFill>
-                  <a:srgbClr val="131416"/>
-                </a:solidFill>
-                <a:latin typeface="Inter"/>
-              </a:rPr>
-              <a:t>4</a:t>
-            </a:r>
-          </a:p>
-        </p:txBody>
-      </p:sp>
-      <p:sp>
-        <p:nvSpPr>
-          <p:cNvPr id="14" name="TextBox 13"/>
+          </a:p>
+        </p:txBody>
+      </p:sp>
+      <p:pic>
+        <p:nvPicPr>
+          <p:cNvPr id="17" name="Picture 16" descr="flag.png"/>
+          <p:cNvPicPr>
+            <a:picLocks noChangeAspect="1"/>
+          </p:cNvPicPr>
+          <p:nvPr/>
+        </p:nvPicPr>
+        <p:blipFill>
+          <a:blip r:embed="rId5"/>
+          <a:stretch>
+            <a:fillRect/>
+          </a:stretch>
+        </p:blipFill>
+        <p:spPr>
+          <a:xfrm>
+            <a:off x="8027608" y="2414930"/>
+            <a:ext cx="427940" cy="427940"/>
+          </a:xfrm>
+          <a:prstGeom prst="rect">
+            <a:avLst/>
+          </a:prstGeom>
+        </p:spPr>
+      </p:pic>
+      <p:sp>
+        <p:nvSpPr>
+          <p:cNvPr id="18" name="TextBox 17"/>
           <p:cNvSpPr txBox="1"/>
           <p:nvPr/>
         </p:nvSpPr>
@@ -7613,14 +7769,14 @@
                 </a:solidFill>
                 <a:latin typeface="DM Sans"/>
               </a:rPr>
-              <a:t>Leadership</a:t>
-            </a:r>
-          </a:p>
-        </p:txBody>
-      </p:sp>
-      <p:sp>
-        <p:nvSpPr>
-          <p:cNvPr id="15" name="TextBox 14"/>
+              <a:t>4. Leadership</a:t>
+            </a:r>
+          </a:p>
+        </p:txBody>
+      </p:sp>
+      <p:sp>
+        <p:nvSpPr>
+          <p:cNvPr id="19" name="TextBox 18"/>
           <p:cNvSpPr txBox="1"/>
           <p:nvPr/>
         </p:nvSpPr>
@@ -7659,14 +7815,14 @@
       </p:sp>
       <p:sp>
         <p:nvSpPr>
-          <p:cNvPr id="16" name="Oval 15"/>
+          <p:cNvPr id="20" name="Oval 19"/>
           <p:cNvSpPr/>
           <p:nvPr/>
         </p:nvSpPr>
         <p:spPr>
           <a:xfrm>
-            <a:off x="10021549" y="2308860"/>
-            <a:ext cx="731520" cy="731520"/>
+            <a:off x="9975829" y="2217420"/>
+            <a:ext cx="822960" cy="822960"/>
           </a:xfrm>
           <a:prstGeom prst="ellipse">
             <a:avLst/>
@@ -7694,25 +7850,40 @@
           </a:fontRef>
         </p:style>
         <p:txBody>
-          <a:bodyPr rtlCol="0" anchor="ctr" lIns="0" rIns="0" tIns="0" bIns="0"/>
+          <a:bodyPr rtlCol="0" anchor="ctr"/>
           <a:lstStyle/>
           <a:p>
             <a:pPr algn="ctr"/>
-            <a:r>
-              <a:rPr sz="2200" b="1" i="0">
-                <a:solidFill>
-                  <a:srgbClr val="131416"/>
-                </a:solidFill>
-                <a:latin typeface="Inter"/>
-              </a:rPr>
-              <a:t>5</a:t>
-            </a:r>
-          </a:p>
-        </p:txBody>
-      </p:sp>
-      <p:sp>
-        <p:nvSpPr>
-          <p:cNvPr id="17" name="TextBox 16"/>
+          </a:p>
+        </p:txBody>
+      </p:sp>
+      <p:pic>
+        <p:nvPicPr>
+          <p:cNvPr id="21" name="Picture 20" descr="plane-takeoff.png"/>
+          <p:cNvPicPr>
+            <a:picLocks noChangeAspect="1"/>
+          </p:cNvPicPr>
+          <p:nvPr/>
+        </p:nvPicPr>
+        <p:blipFill>
+          <a:blip r:embed="rId6"/>
+          <a:stretch>
+            <a:fillRect/>
+          </a:stretch>
+        </p:blipFill>
+        <p:spPr>
+          <a:xfrm>
+            <a:off x="10173339" y="2414930"/>
+            <a:ext cx="427940" cy="427940"/>
+          </a:xfrm>
+          <a:prstGeom prst="rect">
+            <a:avLst/>
+          </a:prstGeom>
+        </p:spPr>
+      </p:pic>
+      <p:sp>
+        <p:nvSpPr>
+          <p:cNvPr id="22" name="TextBox 21"/>
           <p:cNvSpPr txBox="1"/>
           <p:nvPr/>
         </p:nvSpPr>
@@ -7744,14 +7915,14 @@
                 </a:solidFill>
                 <a:latin typeface="DM Sans"/>
               </a:rPr>
-              <a:t>Re-Entry Home</a:t>
-            </a:r>
-          </a:p>
-        </p:txBody>
-      </p:sp>
-      <p:sp>
-        <p:nvSpPr>
-          <p:cNvPr id="18" name="TextBox 17"/>
+              <a:t>5. Re-Entry Home</a:t>
+            </a:r>
+          </a:p>
+        </p:txBody>
+      </p:sp>
+      <p:sp>
+        <p:nvSpPr>
+          <p:cNvPr id="23" name="TextBox 22"/>
           <p:cNvSpPr txBox="1"/>
           <p:nvPr/>
         </p:nvSpPr>
@@ -7790,14 +7961,14 @@
       </p:sp>
       <p:pic>
         <p:nvPicPr>
-          <p:cNvPr id="19" name="Picture 18" descr="logo-icon-deep-blue.png"/>
+          <p:cNvPr id="24" name="Picture 23" descr="logo-icon-deep-blue.png"/>
           <p:cNvPicPr>
             <a:picLocks noChangeAspect="1"/>
           </p:cNvPicPr>
           <p:nvPr/>
         </p:nvPicPr>
         <p:blipFill>
-          <a:blip r:embed="rId2"/>
+          <a:blip r:embed="rId7"/>
           <a:stretch>
             <a:fillRect/>
           </a:stretch>
@@ -7814,7 +7985,7 @@
       </p:pic>
       <p:sp>
         <p:nvSpPr>
-          <p:cNvPr id="20" name="TextBox 19"/>
+          <p:cNvPr id="25" name="TextBox 24"/>
           <p:cNvSpPr txBox="1"/>
           <p:nvPr/>
         </p:nvSpPr>
@@ -8382,7 +8553,7 @@
       <p:grpSpPr/>
       <p:pic>
         <p:nvPicPr>
-          <p:cNvPr id="2" name="Picture 1" descr="img_8600037704479158950.png"/>
+          <p:cNvPr id="2" name="Picture 1" descr="img_9011723992152996071.png"/>
           <p:cNvPicPr>
             <a:picLocks noChangeAspect="1"/>
           </p:cNvPicPr>

</xml_diff>